<commit_message>
Un push más por si falla
</commit_message>
<xml_diff>
--- a/Reporte 030726.pptx
+++ b/Reporte 030726.pptx
@@ -6421,7 +6421,7 @@
                 <a:latin typeface="Montserrat Black"/>
                 <a:sym typeface="Arial"/>
               </a:rPr>
-              <a:t>Elaborado: 02 de julio</a:t>
+              <a:t>Elaborado: 03 de julio</a:t>
             </a:r>
             <a:endParaRPr lang="es-MX" sz="1600" dirty="0">
               <a:solidFill>
@@ -7318,10 +7318,10 @@
       </p:sp>
       <p:pic>
         <p:nvPicPr>
-          <p:cNvPr id="4" name="Imagen 3">
+          <p:cNvPr id="3" name="Imagen 2">
             <a:extLst>
               <a:ext uri="{FF2B5EF4-FFF2-40B4-BE49-F238E27FC236}">
-                <a16:creationId xmlns:a16="http://schemas.microsoft.com/office/drawing/2014/main" id="{42E2E71D-8791-403B-C090-555FB688A300}"/>
+                <a16:creationId xmlns:a16="http://schemas.microsoft.com/office/drawing/2014/main" id="{9C7866FD-C959-BA82-2F51-43CCF958B2E7}"/>
               </a:ext>
             </a:extLst>
           </p:cNvPr>
@@ -7338,8 +7338,8 @@
         </p:blipFill>
         <p:spPr>
           <a:xfrm>
-            <a:off x="0" y="732833"/>
-            <a:ext cx="9144000" cy="3820709"/>
+            <a:off x="0" y="938584"/>
+            <a:ext cx="9144000" cy="3409208"/>
           </a:xfrm>
           <a:prstGeom prst="rect">
             <a:avLst/>
@@ -7432,10 +7432,10 @@
       </p:sp>
       <p:pic>
         <p:nvPicPr>
-          <p:cNvPr id="6" name="Imagen 5">
+          <p:cNvPr id="3" name="Imagen 2">
             <a:extLst>
               <a:ext uri="{FF2B5EF4-FFF2-40B4-BE49-F238E27FC236}">
-                <a16:creationId xmlns:a16="http://schemas.microsoft.com/office/drawing/2014/main" id="{C6261E8E-96DF-A914-D18B-952C2501B7B1}"/>
+                <a16:creationId xmlns:a16="http://schemas.microsoft.com/office/drawing/2014/main" id="{5DF2AB0E-A0DB-C742-2A83-E4F0318BFDB4}"/>
               </a:ext>
             </a:extLst>
           </p:cNvPr>
@@ -7452,8 +7452,8 @@
         </p:blipFill>
         <p:spPr>
           <a:xfrm>
-            <a:off x="0" y="1257884"/>
-            <a:ext cx="9144000" cy="2770607"/>
+            <a:off x="0" y="1406642"/>
+            <a:ext cx="9144000" cy="2473092"/>
           </a:xfrm>
           <a:prstGeom prst="rect">
             <a:avLst/>
@@ -7546,10 +7546,10 @@
       </p:sp>
       <p:pic>
         <p:nvPicPr>
-          <p:cNvPr id="3" name="Imagen 2">
+          <p:cNvPr id="2" name="Imagen 1">
             <a:extLst>
               <a:ext uri="{FF2B5EF4-FFF2-40B4-BE49-F238E27FC236}">
-                <a16:creationId xmlns:a16="http://schemas.microsoft.com/office/drawing/2014/main" id="{47825FB3-D899-1E7B-540C-41BAE8D12ED6}"/>
+                <a16:creationId xmlns:a16="http://schemas.microsoft.com/office/drawing/2014/main" id="{DD4E76EC-1D12-4DA0-550B-1F948E6B32C5}"/>
               </a:ext>
             </a:extLst>
           </p:cNvPr>
@@ -7566,8 +7566,8 @@
         </p:blipFill>
         <p:spPr>
           <a:xfrm>
-            <a:off x="1113385" y="691088"/>
-            <a:ext cx="6844205" cy="3904200"/>
+            <a:off x="1106488" y="975352"/>
+            <a:ext cx="6858000" cy="3456495"/>
           </a:xfrm>
           <a:prstGeom prst="rect">
             <a:avLst/>
@@ -7656,10 +7656,10 @@
       </p:sp>
       <p:pic>
         <p:nvPicPr>
-          <p:cNvPr id="3" name="Imagen 2">
+          <p:cNvPr id="4" name="Imagen 3">
             <a:extLst>
               <a:ext uri="{FF2B5EF4-FFF2-40B4-BE49-F238E27FC236}">
-                <a16:creationId xmlns:a16="http://schemas.microsoft.com/office/drawing/2014/main" id="{24FA7D67-AAAF-1CB9-6C02-72215495ACD1}"/>
+                <a16:creationId xmlns:a16="http://schemas.microsoft.com/office/drawing/2014/main" id="{0AE9074E-9C78-49FE-D19F-7E05EEA9AD7E}"/>
               </a:ext>
             </a:extLst>
           </p:cNvPr>
@@ -7676,8 +7676,8 @@
         </p:blipFill>
         <p:spPr>
           <a:xfrm>
-            <a:off x="123204" y="1438107"/>
-            <a:ext cx="8897592" cy="2410161"/>
+            <a:off x="553481" y="595027"/>
+            <a:ext cx="7964011" cy="4096322"/>
           </a:xfrm>
           <a:prstGeom prst="rect">
             <a:avLst/>
@@ -7770,10 +7770,10 @@
       </p:sp>
       <p:pic>
         <p:nvPicPr>
-          <p:cNvPr id="3" name="Imagen 2">
+          <p:cNvPr id="4" name="Imagen 3">
             <a:extLst>
               <a:ext uri="{FF2B5EF4-FFF2-40B4-BE49-F238E27FC236}">
-                <a16:creationId xmlns:a16="http://schemas.microsoft.com/office/drawing/2014/main" id="{5C7183DC-A074-5F3A-C41F-6C01194FB5EE}"/>
+                <a16:creationId xmlns:a16="http://schemas.microsoft.com/office/drawing/2014/main" id="{71540E33-FF1D-29F1-39C5-65A1587F5FC5}"/>
               </a:ext>
             </a:extLst>
           </p:cNvPr>
@@ -7790,8 +7790,8 @@
         </p:blipFill>
         <p:spPr>
           <a:xfrm>
-            <a:off x="0" y="729155"/>
-            <a:ext cx="9144000" cy="3828065"/>
+            <a:off x="0" y="932391"/>
+            <a:ext cx="9144000" cy="3421594"/>
           </a:xfrm>
           <a:prstGeom prst="rect">
             <a:avLst/>
@@ -7884,10 +7884,10 @@
       </p:sp>
       <p:pic>
         <p:nvPicPr>
-          <p:cNvPr id="2" name="Imagen 1">
+          <p:cNvPr id="3" name="Imagen 2">
             <a:extLst>
               <a:ext uri="{FF2B5EF4-FFF2-40B4-BE49-F238E27FC236}">
-                <a16:creationId xmlns:a16="http://schemas.microsoft.com/office/drawing/2014/main" id="{5113DAC2-95F1-07F1-78F6-0C855E113E43}"/>
+                <a16:creationId xmlns:a16="http://schemas.microsoft.com/office/drawing/2014/main" id="{4895A1DE-F09B-7338-07B8-8E3AF553A7EC}"/>
               </a:ext>
             </a:extLst>
           </p:cNvPr>
@@ -7904,8 +7904,8 @@
         </p:blipFill>
         <p:spPr>
           <a:xfrm>
-            <a:off x="1149897" y="691088"/>
-            <a:ext cx="6844205" cy="3904200"/>
+            <a:off x="1106488" y="914940"/>
+            <a:ext cx="6858000" cy="3456495"/>
           </a:xfrm>
           <a:prstGeom prst="rect">
             <a:avLst/>
@@ -7998,10 +7998,10 @@
       </p:sp>
       <p:pic>
         <p:nvPicPr>
-          <p:cNvPr id="2" name="Imagen 1">
+          <p:cNvPr id="3" name="Imagen 2">
             <a:extLst>
               <a:ext uri="{FF2B5EF4-FFF2-40B4-BE49-F238E27FC236}">
-                <a16:creationId xmlns:a16="http://schemas.microsoft.com/office/drawing/2014/main" id="{6624D387-29FE-BC0F-0131-20495BA5C997}"/>
+                <a16:creationId xmlns:a16="http://schemas.microsoft.com/office/drawing/2014/main" id="{DE37B1B0-0F67-4759-954A-BD81E701B83C}"/>
               </a:ext>
             </a:extLst>
           </p:cNvPr>
@@ -8018,8 +8018,8 @@
         </p:blipFill>
         <p:spPr>
           <a:xfrm>
-            <a:off x="1113385" y="691088"/>
-            <a:ext cx="6844205" cy="3904200"/>
+            <a:off x="1143000" y="914940"/>
+            <a:ext cx="6858000" cy="3456495"/>
           </a:xfrm>
           <a:prstGeom prst="rect">
             <a:avLst/>
@@ -8108,10 +8108,10 @@
       </p:sp>
       <p:pic>
         <p:nvPicPr>
-          <p:cNvPr id="3" name="Imagen 2">
+          <p:cNvPr id="4" name="Imagen 3">
             <a:extLst>
               <a:ext uri="{FF2B5EF4-FFF2-40B4-BE49-F238E27FC236}">
-                <a16:creationId xmlns:a16="http://schemas.microsoft.com/office/drawing/2014/main" id="{1CCD5837-2942-779F-43D2-ACFBCA209E0A}"/>
+                <a16:creationId xmlns:a16="http://schemas.microsoft.com/office/drawing/2014/main" id="{D387B1D2-D267-C57B-2793-0F10D02CD8C8}"/>
               </a:ext>
             </a:extLst>
           </p:cNvPr>
@@ -8128,8 +8128,8 @@
         </p:blipFill>
         <p:spPr>
           <a:xfrm>
-            <a:off x="613810" y="504536"/>
-            <a:ext cx="7916380" cy="4134427"/>
+            <a:off x="815456" y="804606"/>
+            <a:ext cx="7440063" cy="3677163"/>
           </a:xfrm>
           <a:prstGeom prst="rect">
             <a:avLst/>

</xml_diff>